<commit_message>
fix: harden audit contracts for release
</commit_message>
<xml_diff>
--- a/tests/fixtures/corpus/privacy-02.pptx
+++ b/tests/fixtures/corpus/privacy-02.pptx
@@ -9,7 +9,12 @@
 </file>
 
 <file path=ppt/comments/comment1.xml><?xml version="1.0" encoding="utf-8"?>
-<p:cmLst xmlns:p="http://schemas.openxmlformats.org/presentationml/2006/main"/>
+<p:cmLst xmlns:p="http://schemas.openxmlformats.org/presentationml/2006/main">
+  <p:cm authorId="0" idx="1">
+    <p:pos x="0" y="0"/>
+    <p:text>Review this</p:text>
+  </p:cm>
+</p:cmLst>
 </file>
 
 <file path=ppt/slides/slide1.xml><?xml version="1.0" encoding="utf-8"?>

</xml_diff>

<commit_message>
feat: publish reproducible AI PowerPoint benchmark method
</commit_message>
<xml_diff>
--- a/tests/fixtures/corpus/privacy-02.pptx
+++ b/tests/fixtures/corpus/privacy-02.pptx
@@ -6,15 +6,6 @@
   </p:sldIdLst>
   <p:sldSz cx="12192000" cy="6858000" type="screen16x9"/>
 </p:presentation>
-</file>
-
-<file path=ppt/comments/comment1.xml><?xml version="1.0" encoding="utf-8"?>
-<p:cmLst xmlns:p="http://schemas.openxmlformats.org/presentationml/2006/main">
-  <p:cm authorId="0" idx="1">
-    <p:pos x="0" y="0"/>
-    <p:text>Review this</p:text>
-  </p:cm>
-</p:cmLst>
 </file>
 
 <file path=ppt/slides/slide1.xml><?xml version="1.0" encoding="utf-8"?>

</xml_diff>